<commit_message>
Presentación: añade 3 diapositivas de evidencia de ejecución
- Capturas reales de las corridas del notebook (reproducción del avance =
  True, verificación de carga = True, inferencia y simulación de 5 perfiles),
  recortadas del informe técnico, con su explicación.
- Portada: autor Felix Yael.
- Deck pasa de 16 a 19 diapositivas; .pptx y .pdf regenerados.

Co-Authored-By: Claude Opus 4.8 <noreply@anthropic.com>
Claude-Session: https://claude.ai/code/session_011wsHP8x3Y1X6LmCTNwU44e
</commit_message>
<xml_diff>
--- a/reports/presentacion_fase_final.pptx
+++ b/reports/presentacion_fase_final.pptx
@@ -21,9 +21,12 @@
     <p:sldId id="269" r:id="rId15"/>
     <p:sldId id="270" r:id="rId16"/>
     <p:sldId id="271" r:id="rId17"/>
+    <p:sldId id="272" r:id="rId18"/>
+    <p:sldId id="273" r:id="rId19"/>
+    <p:sldId id="274" r:id="rId20"/>
   </p:sldIdLst>
   <p:notesMasterIdLst>
-    <p:notesMasterId r:id="rId18"/>
+    <p:notesMasterId r:id="rId21"/>
   </p:notesMasterIdLst>
   <p:sldSz cx="12191695" cy="6858000"/>
   <p:notesSz cx="6858000" cy="12191695"/>
@@ -1955,7 +1958,7 @@
           <a:p>
             <a:r>
               <a:rPr lang="en-US" dirty="0"/>
-              <a:t>Cierra amarrando todo en cuatro ideas: funciona, es transparente, es reproducible y es prudente. La frase final es tu recomendación: no proponemos automatizar nada, proponemos una prueba controlada donde el modelo acompaña al scouting con monitoreo. Termina invitando a preguntas y, si te lo piden, ofrece mostrar el notebook en vivo o correr una inferencia de ejemplo.</a:t>
+              <a:t>Esta es una captura de la corrida real del notebook, no un dibujo. Explica: volvimos a entrenar los modelos del avance con la misma semilla, el mismo pipeline y la misma validación, y el programa imprime 'Reproducción coincide con el avance: True'. En la tabla, la última columna '¿Coincide?' da 'sí' en cada modelo: las métricas son idénticas a las del avance, cifra por cifra. Esto es lo que garantiza la comparabilidad (regla no-romper-la-comparabilidad): partimos exactamente del mismo punto.</a:t>
             </a:r>
             <a:endParaRPr lang="en-US" dirty="0"/>
           </a:p>
@@ -1979,6 +1982,270 @@
             <a:fld id="{F7021451-1387-4CA6-816F-3879F97B5CBC}" type="slidenum">
               <a:rPr lang="en-US"/>
               <a:t>16</a:t>
+            </a:fld>
+            <a:endParaRPr lang="en-US"/>
+          </a:p>
+        </p:txBody>
+      </p:sp>
+    </p:spTree>
+    <p:extLst>
+      <p:ext uri="{BB962C8B-B14F-4D97-AF65-F5344CB8AC3E}">
+        <p14:creationId xmlns:p14="http://schemas.microsoft.com/office/powerpoint/2010/main" val="1024086991"/>
+      </p:ext>
+    </p:extLst>
+  </p:cSld>
+  <p:clrMapOvr>
+    <a:masterClrMapping/>
+  </p:clrMapOvr>
+</p:notes>
+</file>
+
+<file path=ppt/notesSlides/notesSlide17.xml><?xml version="1.0" encoding="utf-8"?>
+<p:notes xmlns:a="http://schemas.openxmlformats.org/drawingml/2006/main" xmlns:r="http://schemas.openxmlformats.org/officeDocument/2006/relationships" xmlns:p="http://schemas.openxmlformats.org/presentationml/2006/main">
+  <p:cSld>
+    <p:spTree>
+      <p:nvGrpSpPr>
+        <p:cNvPr id="1" name=""/>
+        <p:cNvGrpSpPr/>
+        <p:nvPr/>
+      </p:nvGrpSpPr>
+      <p:grpSpPr>
+        <a:xfrm>
+          <a:off x="0" y="0"/>
+          <a:ext cx="0" cy="0"/>
+          <a:chOff x="0" y="0"/>
+          <a:chExt cx="0" cy="0"/>
+        </a:xfrm>
+      </p:grpSpPr>
+      <p:sp>
+        <p:nvSpPr>
+          <p:cNvPr id="2" name="Slide Image Placeholder 1"/>
+          <p:cNvSpPr>
+            <a:spLocks noGrp="1" noRot="1" noChangeAspect="1"/>
+          </p:cNvSpPr>
+          <p:nvPr>
+            <p:ph type="sldImg"/>
+          </p:nvPr>
+        </p:nvSpPr>
+        <p:spPr/>
+      </p:sp>
+      <p:sp>
+        <p:nvSpPr>
+          <p:cNvPr id="3" name="Notes Placeholder 2"/>
+          <p:cNvSpPr>
+            <a:spLocks noGrp="1"/>
+          </p:cNvSpPr>
+          <p:nvPr>
+            <p:ph type="body" idx="1"/>
+          </p:nvPr>
+        </p:nvSpPr>
+        <p:spPr/>
+        <p:txBody>
+          <a:bodyPr/>
+          <a:lstStyle/>
+          <a:p>
+            <a:r>
+              <a:rPr lang="en-US" dirty="0"/>
+              <a:t>Segunda corrida real. Arriba: recargamos el modelo ya guardado en disco (verificando su hash de integridad) y el programa confirma 'Verificación de carga: True', es decir, el modelo serializado da EXACTAMENTE las mismas predicciones que antes de guardarlo; eso prueba que el artefacto que se entrega funciona. Abajo: lo usamos para predecir sobre dos jugadores nuevos; para cada uno devuelve la probabilidad de LCK, la clasificación, el umbral (0.40) y el mensaje obligatorio de revisión humana. Es el mecanismo de inferencia funcionando de punta a punta.</a:t>
+            </a:r>
+            <a:endParaRPr lang="en-US" dirty="0"/>
+          </a:p>
+        </p:txBody>
+      </p:sp>
+      <p:sp>
+        <p:nvSpPr>
+          <p:cNvPr id="4" name="Slide Number Placeholder 3"/>
+          <p:cNvSpPr>
+            <a:spLocks noGrp="1"/>
+          </p:cNvSpPr>
+          <p:nvPr>
+            <p:ph type="sldNum" sz="quarter" idx="10"/>
+          </p:nvPr>
+        </p:nvSpPr>
+        <p:spPr/>
+        <p:txBody>
+          <a:bodyPr/>
+          <a:lstStyle/>
+          <a:p>
+            <a:fld id="{F7021451-1387-4CA6-816F-3879F97B5CBC}" type="slidenum">
+              <a:rPr lang="en-US"/>
+              <a:t>17</a:t>
+            </a:fld>
+            <a:endParaRPr lang="en-US"/>
+          </a:p>
+        </p:txBody>
+      </p:sp>
+    </p:spTree>
+    <p:extLst>
+      <p:ext uri="{BB962C8B-B14F-4D97-AF65-F5344CB8AC3E}">
+        <p14:creationId xmlns:p14="http://schemas.microsoft.com/office/powerpoint/2010/main" val="1024086991"/>
+      </p:ext>
+    </p:extLst>
+  </p:cSld>
+  <p:clrMapOvr>
+    <a:masterClrMapping/>
+  </p:clrMapOvr>
+</p:notes>
+</file>
+
+<file path=ppt/notesSlides/notesSlide18.xml><?xml version="1.0" encoding="utf-8"?>
+<p:notes xmlns:a="http://schemas.openxmlformats.org/drawingml/2006/main" xmlns:r="http://schemas.openxmlformats.org/officeDocument/2006/relationships" xmlns:p="http://schemas.openxmlformats.org/presentationml/2006/main">
+  <p:cSld>
+    <p:spTree>
+      <p:nvGrpSpPr>
+        <p:cNvPr id="1" name=""/>
+        <p:cNvGrpSpPr/>
+        <p:nvPr/>
+      </p:nvGrpSpPr>
+      <p:grpSpPr>
+        <a:xfrm>
+          <a:off x="0" y="0"/>
+          <a:ext cx="0" cy="0"/>
+          <a:chOff x="0" y="0"/>
+          <a:chExt cx="0" cy="0"/>
+        </a:xfrm>
+      </p:grpSpPr>
+      <p:sp>
+        <p:nvSpPr>
+          <p:cNvPr id="2" name="Slide Image Placeholder 1"/>
+          <p:cNvSpPr>
+            <a:spLocks noGrp="1" noRot="1" noChangeAspect="1"/>
+          </p:cNvSpPr>
+          <p:nvPr>
+            <p:ph type="sldImg"/>
+          </p:nvPr>
+        </p:nvSpPr>
+        <p:spPr/>
+      </p:sp>
+      <p:sp>
+        <p:nvSpPr>
+          <p:cNvPr id="3" name="Notes Placeholder 2"/>
+          <p:cNvSpPr>
+            <a:spLocks noGrp="1"/>
+          </p:cNvSpPr>
+          <p:nvPr>
+            <p:ph type="body" idx="1"/>
+          </p:nvPr>
+        </p:nvSpPr>
+        <p:spPr/>
+        <p:txBody>
+          <a:bodyPr/>
+          <a:lstStyle/>
+          <a:p>
+            <a:r>
+              <a:rPr lang="en-US" dirty="0"/>
+              <a:t>Tercera corrida real: pasamos por el modelo cinco perfiles de jugador distintos. Señala en la tabla: el perfil de alto rendimiento sale 0.99 (LCK) y el bajo 0.01 (LCK CL), o sea que separa bien los casos claros. El interesante es el 'Cercano al umbral', que da 0.40: es un caso dudoso, y ahí es donde el criterio humano es imprescindible. Y la 'Categoría rara' usa una posición que el modelo nunca vio ('jungla'): en vez de fallar, la procesa sin romper gracias al manejo de categorías desconocidas. Cierra repitiendo: ninguna de estas decisiones se automatiza.</a:t>
+            </a:r>
+            <a:endParaRPr lang="en-US" dirty="0"/>
+          </a:p>
+        </p:txBody>
+      </p:sp>
+      <p:sp>
+        <p:nvSpPr>
+          <p:cNvPr id="4" name="Slide Number Placeholder 3"/>
+          <p:cNvSpPr>
+            <a:spLocks noGrp="1"/>
+          </p:cNvSpPr>
+          <p:nvPr>
+            <p:ph type="sldNum" sz="quarter" idx="10"/>
+          </p:nvPr>
+        </p:nvSpPr>
+        <p:spPr/>
+        <p:txBody>
+          <a:bodyPr/>
+          <a:lstStyle/>
+          <a:p>
+            <a:fld id="{F7021451-1387-4CA6-816F-3879F97B5CBC}" type="slidenum">
+              <a:rPr lang="en-US"/>
+              <a:t>18</a:t>
+            </a:fld>
+            <a:endParaRPr lang="en-US"/>
+          </a:p>
+        </p:txBody>
+      </p:sp>
+    </p:spTree>
+    <p:extLst>
+      <p:ext uri="{BB962C8B-B14F-4D97-AF65-F5344CB8AC3E}">
+        <p14:creationId xmlns:p14="http://schemas.microsoft.com/office/powerpoint/2010/main" val="1024086991"/>
+      </p:ext>
+    </p:extLst>
+  </p:cSld>
+  <p:clrMapOvr>
+    <a:masterClrMapping/>
+  </p:clrMapOvr>
+</p:notes>
+</file>
+
+<file path=ppt/notesSlides/notesSlide19.xml><?xml version="1.0" encoding="utf-8"?>
+<p:notes xmlns:a="http://schemas.openxmlformats.org/drawingml/2006/main" xmlns:r="http://schemas.openxmlformats.org/officeDocument/2006/relationships" xmlns:p="http://schemas.openxmlformats.org/presentationml/2006/main">
+  <p:cSld>
+    <p:spTree>
+      <p:nvGrpSpPr>
+        <p:cNvPr id="1" name=""/>
+        <p:cNvGrpSpPr/>
+        <p:nvPr/>
+      </p:nvGrpSpPr>
+      <p:grpSpPr>
+        <a:xfrm>
+          <a:off x="0" y="0"/>
+          <a:ext cx="0" cy="0"/>
+          <a:chOff x="0" y="0"/>
+          <a:chExt cx="0" cy="0"/>
+        </a:xfrm>
+      </p:grpSpPr>
+      <p:sp>
+        <p:nvSpPr>
+          <p:cNvPr id="2" name="Slide Image Placeholder 1"/>
+          <p:cNvSpPr>
+            <a:spLocks noGrp="1" noRot="1" noChangeAspect="1"/>
+          </p:cNvSpPr>
+          <p:nvPr>
+            <p:ph type="sldImg"/>
+          </p:nvPr>
+        </p:nvSpPr>
+        <p:spPr/>
+      </p:sp>
+      <p:sp>
+        <p:nvSpPr>
+          <p:cNvPr id="3" name="Notes Placeholder 2"/>
+          <p:cNvSpPr>
+            <a:spLocks noGrp="1"/>
+          </p:cNvSpPr>
+          <p:nvPr>
+            <p:ph type="body" idx="1"/>
+          </p:nvPr>
+        </p:nvSpPr>
+        <p:spPr/>
+        <p:txBody>
+          <a:bodyPr/>
+          <a:lstStyle/>
+          <a:p>
+            <a:r>
+              <a:rPr lang="en-US" dirty="0"/>
+              <a:t>Cierra amarrando todo en cuatro ideas: funciona, es transparente, es reproducible y es prudente. La frase final es tu recomendación: no proponemos automatizar nada, proponemos una prueba controlada donde el modelo acompaña al scouting con monitoreo. Termina invitando a preguntas y, si te lo piden, ofrece mostrar el notebook en vivo o correr una inferencia de ejemplo.</a:t>
+            </a:r>
+            <a:endParaRPr lang="en-US" dirty="0"/>
+          </a:p>
+        </p:txBody>
+      </p:sp>
+      <p:sp>
+        <p:nvSpPr>
+          <p:cNvPr id="4" name="Slide Number Placeholder 3"/>
+          <p:cNvSpPr>
+            <a:spLocks noGrp="1"/>
+          </p:cNvSpPr>
+          <p:nvPr>
+            <p:ph type="sldNum" sz="quarter" idx="10"/>
+          </p:nvPr>
+        </p:nvSpPr>
+        <p:spPr/>
+        <p:txBody>
+          <a:bodyPr/>
+          <a:lstStyle/>
+          <a:p>
+            <a:fld id="{F7021451-1387-4CA6-816F-3879F97B5CBC}" type="slidenum">
+              <a:rPr lang="en-US"/>
+              <a:t>19</a:t>
             </a:fld>
             <a:endParaRPr lang="en-US"/>
           </a:p>
@@ -3257,7 +3524,7 @@
                 <a:ea typeface="Calibri" pitchFamily="34" charset="-122"/>
                 <a:cs typeface="Calibri" pitchFamily="34" charset="-120"/>
               </a:rPr>
-              <a:t>[Tu nombre]   </a:t>
+              <a:t>Felix Yael   </a:t>
             </a:r>
             <a:pPr indent="0" marL="0">
               <a:buNone/>
@@ -7406,6 +7673,1169 @@
     <p:bg>
       <p:bgPr>
         <a:solidFill>
+          <a:srgbClr val="0E1530"/>
+        </a:solidFill>
+      </p:bgPr>
+    </p:bg>
+    <p:spTree>
+      <p:nvGrpSpPr>
+        <p:cNvPr id="1" name=""/>
+        <p:cNvGrpSpPr/>
+        <p:nvPr/>
+      </p:nvGrpSpPr>
+      <p:grpSpPr>
+        <a:xfrm>
+          <a:off x="0" y="0"/>
+          <a:ext cx="0" cy="0"/>
+          <a:chOff x="0" y="0"/>
+          <a:chExt cx="0" cy="0"/>
+        </a:xfrm>
+      </p:grpSpPr>
+      <p:sp>
+        <p:nvSpPr>
+          <p:cNvPr id="2" name="Text 0"/>
+          <p:cNvSpPr txBox="1"/>
+          <p:nvPr/>
+        </p:nvSpPr>
+        <p:spPr>
+          <a:xfrm>
+            <a:off x="548640" y="457200"/>
+            <a:ext cx="8229600" cy="274320"/>
+          </a:xfrm>
+          <a:prstGeom prst="rect">
+            <a:avLst/>
+          </a:prstGeom>
+          <a:noFill/>
+          <a:ln/>
+        </p:spPr>
+        <p:txBody>
+          <a:bodyPr wrap="square" lIns="0" tIns="0" rIns="0" bIns="0" rtlCol="0" anchor="ctr"/>
+          <a:lstStyle/>
+          <a:p>
+            <a:pPr indent="0" marL="0">
+              <a:buNone/>
+            </a:pPr>
+            <a:r>
+              <a:rPr lang="en-US" sz="1200" b="1" spc="300" kern="0" dirty="0">
+                <a:solidFill>
+                  <a:srgbClr val="F2B84B"/>
+                </a:solidFill>
+                <a:latin typeface="Calibri" pitchFamily="34" charset="0"/>
+                <a:ea typeface="Calibri" pitchFamily="34" charset="-122"/>
+                <a:cs typeface="Calibri" pitchFamily="34" charset="-120"/>
+              </a:rPr>
+              <a:t>EVIDENCIA DE EJECUCIÓN</a:t>
+            </a:r>
+            <a:endParaRPr lang="en-US" sz="1200" dirty="0"/>
+          </a:p>
+        </p:txBody>
+      </p:sp>
+      <p:sp>
+        <p:nvSpPr>
+          <p:cNvPr id="3" name="Text 1"/>
+          <p:cNvSpPr txBox="1"/>
+          <p:nvPr/>
+        </p:nvSpPr>
+        <p:spPr>
+          <a:xfrm>
+            <a:off x="548640" y="749808"/>
+            <a:ext cx="11064240" cy="822960"/>
+          </a:xfrm>
+          <a:prstGeom prst="rect">
+            <a:avLst/>
+          </a:prstGeom>
+          <a:noFill/>
+          <a:ln/>
+        </p:spPr>
+        <p:txBody>
+          <a:bodyPr wrap="square" lIns="0" tIns="0" rIns="0" bIns="0" rtlCol="0" anchor="ctr"/>
+          <a:lstStyle/>
+          <a:p>
+            <a:pPr indent="0" marL="0">
+              <a:buNone/>
+            </a:pPr>
+            <a:r>
+              <a:rPr lang="en-US" sz="3400" b="1" dirty="0">
+                <a:solidFill>
+                  <a:srgbClr val="EAF0FF"/>
+                </a:solidFill>
+                <a:latin typeface="Cambria" pitchFamily="34" charset="0"/>
+                <a:ea typeface="Cambria" pitchFamily="34" charset="-122"/>
+                <a:cs typeface="Cambria" pitchFamily="34" charset="-120"/>
+              </a:rPr>
+              <a:t>Ejecución 1 · Reproducción del avance</a:t>
+            </a:r>
+            <a:endParaRPr lang="en-US" sz="3400" dirty="0"/>
+          </a:p>
+        </p:txBody>
+      </p:sp>
+      <p:sp>
+        <p:nvSpPr>
+          <p:cNvPr id="4" name="Text 2"/>
+          <p:cNvSpPr txBox="1"/>
+          <p:nvPr/>
+        </p:nvSpPr>
+        <p:spPr>
+          <a:xfrm>
+            <a:off x="11430000" y="6355080"/>
+            <a:ext cx="548640" cy="274320"/>
+          </a:xfrm>
+          <a:prstGeom prst="rect">
+            <a:avLst/>
+          </a:prstGeom>
+          <a:noFill/>
+          <a:ln/>
+        </p:spPr>
+        <p:txBody>
+          <a:bodyPr wrap="square" lIns="0" tIns="0" rIns="0" bIns="0" rtlCol="0" anchor="ctr"/>
+          <a:lstStyle/>
+          <a:p>
+            <a:pPr algn="r" indent="0" marL="0">
+              <a:buNone/>
+            </a:pPr>
+            <a:r>
+              <a:rPr lang="en-US" sz="1000" dirty="0">
+                <a:solidFill>
+                  <a:srgbClr val="97A6CF"/>
+                </a:solidFill>
+                <a:latin typeface="Calibri" pitchFamily="34" charset="0"/>
+                <a:ea typeface="Calibri" pitchFamily="34" charset="-122"/>
+                <a:cs typeface="Calibri" pitchFamily="34" charset="-120"/>
+              </a:rPr>
+              <a:t>16</a:t>
+            </a:r>
+            <a:endParaRPr lang="en-US" sz="1000" dirty="0"/>
+          </a:p>
+        </p:txBody>
+      </p:sp>
+      <p:pic>
+        <p:nvPicPr>
+          <p:cNvPr id="5" name="Image 0" descr="preencoded.png">    </p:cNvPr>
+          <p:cNvPicPr>
+            <a:picLocks noChangeAspect="1"/>
+          </p:cNvPicPr>
+          <p:nvPr/>
+        </p:nvPicPr>
+        <p:blipFill>
+          <a:blip r:embed="rId1"/>
+          <a:stretch>
+            <a:fillRect/>
+          </a:stretch>
+        </p:blipFill>
+        <p:spPr>
+          <a:xfrm>
+            <a:off x="548640" y="1783080"/>
+            <a:ext cx="6766560" cy="4892040"/>
+          </a:xfrm>
+          <a:prstGeom prst="rect">
+            <a:avLst/>
+          </a:prstGeom>
+        </p:spPr>
+      </p:pic>
+      <p:sp>
+        <p:nvSpPr>
+          <p:cNvPr id="6" name="Shape 3"/>
+          <p:cNvSpPr/>
+          <p:nvPr/>
+        </p:nvSpPr>
+        <p:spPr>
+          <a:xfrm>
+            <a:off x="7589520" y="1783080"/>
+            <a:ext cx="4023360" cy="4892040"/>
+          </a:xfrm>
+          <a:prstGeom prst="roundRect">
+            <a:avLst>
+              <a:gd name="adj" fmla="val 2045"/>
+            </a:avLst>
+          </a:prstGeom>
+          <a:solidFill>
+            <a:srgbClr val="1A2350"/>
+          </a:solidFill>
+          <a:ln/>
+        </p:spPr>
+      </p:sp>
+      <p:sp>
+        <p:nvSpPr>
+          <p:cNvPr id="7" name="Text 4"/>
+          <p:cNvSpPr txBox="1"/>
+          <p:nvPr/>
+        </p:nvSpPr>
+        <p:spPr>
+          <a:xfrm>
+            <a:off x="7863840" y="2011680"/>
+            <a:ext cx="3474720" cy="365760"/>
+          </a:xfrm>
+          <a:prstGeom prst="rect">
+            <a:avLst/>
+          </a:prstGeom>
+          <a:noFill/>
+          <a:ln/>
+        </p:spPr>
+        <p:txBody>
+          <a:bodyPr wrap="square" lIns="0" tIns="0" rIns="0" bIns="0" rtlCol="0" anchor="ctr"/>
+          <a:lstStyle/>
+          <a:p>
+            <a:pPr indent="0" marL="0">
+              <a:buNone/>
+            </a:pPr>
+            <a:r>
+              <a:rPr lang="en-US" sz="1800" b="1" dirty="0">
+                <a:solidFill>
+                  <a:srgbClr val="F2B84B"/>
+                </a:solidFill>
+                <a:latin typeface="Cambria" pitchFamily="34" charset="0"/>
+                <a:ea typeface="Cambria" pitchFamily="34" charset="-122"/>
+                <a:cs typeface="Cambria" pitchFamily="34" charset="-120"/>
+              </a:rPr>
+              <a:t>Qué se ve aquí</a:t>
+            </a:r>
+            <a:endParaRPr lang="en-US" sz="1800" dirty="0"/>
+          </a:p>
+        </p:txBody>
+      </p:sp>
+      <p:sp>
+        <p:nvSpPr>
+          <p:cNvPr id="8" name="Text 5"/>
+          <p:cNvSpPr txBox="1"/>
+          <p:nvPr/>
+        </p:nvSpPr>
+        <p:spPr>
+          <a:xfrm>
+            <a:off x="7863840" y="2468880"/>
+            <a:ext cx="3474720" cy="1554480"/>
+          </a:xfrm>
+          <a:prstGeom prst="rect">
+            <a:avLst/>
+          </a:prstGeom>
+          <a:noFill/>
+          <a:ln/>
+        </p:spPr>
+        <p:txBody>
+          <a:bodyPr wrap="square" lIns="0" tIns="0" rIns="0" bIns="0" rtlCol="0" anchor="ctr"/>
+          <a:lstStyle/>
+          <a:p>
+            <a:pPr indent="0" marL="0">
+              <a:lnSpc>
+                <a:spcPct val="120000"/>
+              </a:lnSpc>
+              <a:buNone/>
+            </a:pPr>
+            <a:r>
+              <a:rPr lang="en-US" sz="1450" b="1" dirty="0">
+                <a:solidFill>
+                  <a:srgbClr val="3AD6C6"/>
+                </a:solidFill>
+                <a:latin typeface="Calibri" pitchFamily="34" charset="0"/>
+                <a:ea typeface="Calibri" pitchFamily="34" charset="-122"/>
+                <a:cs typeface="Calibri" pitchFamily="34" charset="-120"/>
+              </a:rPr>
+              <a:t>Salida real del notebook. </a:t>
+            </a:r>
+            <a:endParaRPr lang="en-US" sz="1450" dirty="0"/>
+          </a:p>
+          <a:p>
+            <a:pPr indent="0" marL="0">
+              <a:lnSpc>
+                <a:spcPct val="120000"/>
+              </a:lnSpc>
+              <a:buNone/>
+            </a:pPr>
+            <a:r>
+              <a:rPr lang="en-US" sz="1450" dirty="0">
+                <a:solidFill>
+                  <a:srgbClr val="EAF0FF"/>
+                </a:solidFill>
+                <a:latin typeface="Calibri" pitchFamily="34" charset="0"/>
+                <a:ea typeface="Calibri" pitchFamily="34" charset="-122"/>
+                <a:cs typeface="Calibri" pitchFamily="34" charset="-120"/>
+              </a:rPr>
+              <a:t>Se re-ejecutan los modelos del avance con la misma semilla, pipeline y validación.</a:t>
+            </a:r>
+            <a:endParaRPr lang="en-US" sz="1450" dirty="0"/>
+          </a:p>
+        </p:txBody>
+      </p:sp>
+      <p:sp>
+        <p:nvSpPr>
+          <p:cNvPr id="9" name="Text 6"/>
+          <p:cNvSpPr txBox="1"/>
+          <p:nvPr/>
+        </p:nvSpPr>
+        <p:spPr>
+          <a:xfrm>
+            <a:off x="7863840" y="4069080"/>
+            <a:ext cx="3474720" cy="1828800"/>
+          </a:xfrm>
+          <a:prstGeom prst="rect">
+            <a:avLst/>
+          </a:prstGeom>
+          <a:noFill/>
+          <a:ln/>
+        </p:spPr>
+        <p:txBody>
+          <a:bodyPr wrap="square" lIns="0" tIns="0" rIns="0" bIns="0" rtlCol="0" anchor="ctr"/>
+          <a:lstStyle/>
+          <a:p>
+            <a:pPr indent="0" marL="0">
+              <a:lnSpc>
+                <a:spcPct val="120000"/>
+              </a:lnSpc>
+              <a:buNone/>
+            </a:pPr>
+            <a:r>
+              <a:rPr lang="en-US" sz="1450" b="1" dirty="0">
+                <a:solidFill>
+                  <a:srgbClr val="3AD6C6"/>
+                </a:solidFill>
+                <a:latin typeface="Calibri" pitchFamily="34" charset="0"/>
+                <a:ea typeface="Calibri" pitchFamily="34" charset="-122"/>
+                <a:cs typeface="Calibri" pitchFamily="34" charset="-120"/>
+              </a:rPr>
+              <a:t>Reproducción coincide = True</a:t>
+            </a:r>
+            <a:endParaRPr lang="en-US" sz="1450" dirty="0"/>
+          </a:p>
+          <a:p>
+            <a:pPr indent="0" marL="0">
+              <a:lnSpc>
+                <a:spcPct val="120000"/>
+              </a:lnSpc>
+              <a:buNone/>
+            </a:pPr>
+            <a:r>
+              <a:rPr lang="en-US" sz="1450" dirty="0">
+                <a:solidFill>
+                  <a:srgbClr val="EAF0FF"/>
+                </a:solidFill>
+                <a:latin typeface="Calibri" pitchFamily="34" charset="0"/>
+                <a:ea typeface="Calibri" pitchFamily="34" charset="-122"/>
+                <a:cs typeface="Calibri" pitchFamily="34" charset="-120"/>
+              </a:rPr>
+              <a:t>y la columna “¿Coincide?” da “sí” en todos: los números son idénticos bit a bit a los del avance.</a:t>
+            </a:r>
+            <a:endParaRPr lang="en-US" sz="1450" dirty="0"/>
+          </a:p>
+        </p:txBody>
+      </p:sp>
+    </p:spTree>
+  </p:cSld>
+  <p:clrMapOvr>
+    <a:masterClrMapping/>
+  </p:clrMapOvr>
+</p:sld>
+</file>
+
+<file path=ppt/slides/slide17.xml><?xml version="1.0" encoding="utf-8"?>
+<p:sld xmlns:a="http://schemas.openxmlformats.org/drawingml/2006/main" xmlns:r="http://schemas.openxmlformats.org/officeDocument/2006/relationships" xmlns:p="http://schemas.openxmlformats.org/presentationml/2006/main">
+  <p:cSld name="Slide 17">
+    <p:bg>
+      <p:bgPr>
+        <a:solidFill>
+          <a:srgbClr val="0E1530"/>
+        </a:solidFill>
+      </p:bgPr>
+    </p:bg>
+    <p:spTree>
+      <p:nvGrpSpPr>
+        <p:cNvPr id="1" name=""/>
+        <p:cNvGrpSpPr/>
+        <p:nvPr/>
+      </p:nvGrpSpPr>
+      <p:grpSpPr>
+        <a:xfrm>
+          <a:off x="0" y="0"/>
+          <a:ext cx="0" cy="0"/>
+          <a:chOff x="0" y="0"/>
+          <a:chExt cx="0" cy="0"/>
+        </a:xfrm>
+      </p:grpSpPr>
+      <p:sp>
+        <p:nvSpPr>
+          <p:cNvPr id="2" name="Text 0"/>
+          <p:cNvSpPr txBox="1"/>
+          <p:nvPr/>
+        </p:nvSpPr>
+        <p:spPr>
+          <a:xfrm>
+            <a:off x="548640" y="457200"/>
+            <a:ext cx="8229600" cy="274320"/>
+          </a:xfrm>
+          <a:prstGeom prst="rect">
+            <a:avLst/>
+          </a:prstGeom>
+          <a:noFill/>
+          <a:ln/>
+        </p:spPr>
+        <p:txBody>
+          <a:bodyPr wrap="square" lIns="0" tIns="0" rIns="0" bIns="0" rtlCol="0" anchor="ctr"/>
+          <a:lstStyle/>
+          <a:p>
+            <a:pPr indent="0" marL="0">
+              <a:buNone/>
+            </a:pPr>
+            <a:r>
+              <a:rPr lang="en-US" sz="1200" b="1" spc="300" kern="0" dirty="0">
+                <a:solidFill>
+                  <a:srgbClr val="F2B84B"/>
+                </a:solidFill>
+                <a:latin typeface="Calibri" pitchFamily="34" charset="0"/>
+                <a:ea typeface="Calibri" pitchFamily="34" charset="-122"/>
+                <a:cs typeface="Calibri" pitchFamily="34" charset="-120"/>
+              </a:rPr>
+              <a:t>EVIDENCIA DE EJECUCIÓN</a:t>
+            </a:r>
+            <a:endParaRPr lang="en-US" sz="1200" dirty="0"/>
+          </a:p>
+        </p:txBody>
+      </p:sp>
+      <p:sp>
+        <p:nvSpPr>
+          <p:cNvPr id="3" name="Text 1"/>
+          <p:cNvSpPr txBox="1"/>
+          <p:nvPr/>
+        </p:nvSpPr>
+        <p:spPr>
+          <a:xfrm>
+            <a:off x="548640" y="749808"/>
+            <a:ext cx="11064240" cy="822960"/>
+          </a:xfrm>
+          <a:prstGeom prst="rect">
+            <a:avLst/>
+          </a:prstGeom>
+          <a:noFill/>
+          <a:ln/>
+        </p:spPr>
+        <p:txBody>
+          <a:bodyPr wrap="square" lIns="0" tIns="0" rIns="0" bIns="0" rtlCol="0" anchor="ctr"/>
+          <a:lstStyle/>
+          <a:p>
+            <a:pPr indent="0" marL="0">
+              <a:buNone/>
+            </a:pPr>
+            <a:r>
+              <a:rPr lang="en-US" sz="3400" b="1" dirty="0">
+                <a:solidFill>
+                  <a:srgbClr val="EAF0FF"/>
+                </a:solidFill>
+                <a:latin typeface="Cambria" pitchFamily="34" charset="0"/>
+                <a:ea typeface="Cambria" pitchFamily="34" charset="-122"/>
+                <a:cs typeface="Cambria" pitchFamily="34" charset="-120"/>
+              </a:rPr>
+              <a:t>Ejecución 2 · Carga del modelo e inferencia</a:t>
+            </a:r>
+            <a:endParaRPr lang="en-US" sz="3400" dirty="0"/>
+          </a:p>
+        </p:txBody>
+      </p:sp>
+      <p:sp>
+        <p:nvSpPr>
+          <p:cNvPr id="4" name="Text 2"/>
+          <p:cNvSpPr txBox="1"/>
+          <p:nvPr/>
+        </p:nvSpPr>
+        <p:spPr>
+          <a:xfrm>
+            <a:off x="11430000" y="6355080"/>
+            <a:ext cx="548640" cy="274320"/>
+          </a:xfrm>
+          <a:prstGeom prst="rect">
+            <a:avLst/>
+          </a:prstGeom>
+          <a:noFill/>
+          <a:ln/>
+        </p:spPr>
+        <p:txBody>
+          <a:bodyPr wrap="square" lIns="0" tIns="0" rIns="0" bIns="0" rtlCol="0" anchor="ctr"/>
+          <a:lstStyle/>
+          <a:p>
+            <a:pPr algn="r" indent="0" marL="0">
+              <a:buNone/>
+            </a:pPr>
+            <a:r>
+              <a:rPr lang="en-US" sz="1000" dirty="0">
+                <a:solidFill>
+                  <a:srgbClr val="97A6CF"/>
+                </a:solidFill>
+                <a:latin typeface="Calibri" pitchFamily="34" charset="0"/>
+                <a:ea typeface="Calibri" pitchFamily="34" charset="-122"/>
+                <a:cs typeface="Calibri" pitchFamily="34" charset="-120"/>
+              </a:rPr>
+              <a:t>17</a:t>
+            </a:r>
+            <a:endParaRPr lang="en-US" sz="1000" dirty="0"/>
+          </a:p>
+        </p:txBody>
+      </p:sp>
+      <p:sp>
+        <p:nvSpPr>
+          <p:cNvPr id="5" name="Text 3"/>
+          <p:cNvSpPr txBox="1"/>
+          <p:nvPr/>
+        </p:nvSpPr>
+        <p:spPr>
+          <a:xfrm>
+            <a:off x="548640" y="1645920"/>
+            <a:ext cx="6949440" cy="457200"/>
+          </a:xfrm>
+          <a:prstGeom prst="rect">
+            <a:avLst/>
+          </a:prstGeom>
+          <a:noFill/>
+          <a:ln/>
+        </p:spPr>
+        <p:txBody>
+          <a:bodyPr wrap="square" lIns="0" tIns="0" rIns="0" bIns="0" rtlCol="0" anchor="ctr"/>
+          <a:lstStyle/>
+          <a:p>
+            <a:pPr indent="0" marL="0">
+              <a:buNone/>
+            </a:pPr>
+            <a:r>
+              <a:rPr lang="en-US" sz="1400" i="1" dirty="0">
+                <a:solidFill>
+                  <a:srgbClr val="97A6CF"/>
+                </a:solidFill>
+                <a:latin typeface="Calibri" pitchFamily="34" charset="0"/>
+                <a:ea typeface="Calibri" pitchFamily="34" charset="-122"/>
+                <a:cs typeface="Calibri" pitchFamily="34" charset="-120"/>
+              </a:rPr>
+              <a:t>Se recarga el modelo guardado (hash verificado); sus predicciones coinciden con las de antes de guardar:</a:t>
+            </a:r>
+            <a:endParaRPr lang="en-US" sz="1400" dirty="0"/>
+          </a:p>
+        </p:txBody>
+      </p:sp>
+      <p:pic>
+        <p:nvPicPr>
+          <p:cNvPr id="6" name="Image 0" descr="preencoded.png">    </p:cNvPr>
+          <p:cNvPicPr>
+            <a:picLocks noChangeAspect="1"/>
+          </p:cNvPicPr>
+          <p:nvPr/>
+        </p:nvPicPr>
+        <p:blipFill>
+          <a:blip r:embed="rId1"/>
+          <a:stretch>
+            <a:fillRect/>
+          </a:stretch>
+        </p:blipFill>
+        <p:spPr>
+          <a:xfrm>
+            <a:off x="548640" y="2148840"/>
+            <a:ext cx="6949440" cy="1609344"/>
+          </a:xfrm>
+          <a:prstGeom prst="rect">
+            <a:avLst/>
+          </a:prstGeom>
+        </p:spPr>
+      </p:pic>
+      <p:sp>
+        <p:nvSpPr>
+          <p:cNvPr id="7" name="Text 4"/>
+          <p:cNvSpPr txBox="1"/>
+          <p:nvPr/>
+        </p:nvSpPr>
+        <p:spPr>
+          <a:xfrm>
+            <a:off x="548640" y="3886200"/>
+            <a:ext cx="6949440" cy="457200"/>
+          </a:xfrm>
+          <a:prstGeom prst="rect">
+            <a:avLst/>
+          </a:prstGeom>
+          <a:noFill/>
+          <a:ln/>
+        </p:spPr>
+        <p:txBody>
+          <a:bodyPr wrap="square" lIns="0" tIns="0" rIns="0" bIns="0" rtlCol="0" anchor="ctr"/>
+          <a:lstStyle/>
+          <a:p>
+            <a:pPr indent="0" marL="0">
+              <a:buNone/>
+            </a:pPr>
+            <a:r>
+              <a:rPr lang="en-US" sz="1400" i="1" dirty="0">
+                <a:solidFill>
+                  <a:srgbClr val="97A6CF"/>
+                </a:solidFill>
+                <a:latin typeface="Calibri" pitchFamily="34" charset="0"/>
+                <a:ea typeface="Calibri" pitchFamily="34" charset="-122"/>
+                <a:cs typeface="Calibri" pitchFamily="34" charset="-120"/>
+              </a:rPr>
+              <a:t>Y predice sobre registros nuevos: probabilidad, clasificación, umbral y aviso de revisión humana:</a:t>
+            </a:r>
+            <a:endParaRPr lang="en-US" sz="1400" dirty="0"/>
+          </a:p>
+        </p:txBody>
+      </p:sp>
+      <p:pic>
+        <p:nvPicPr>
+          <p:cNvPr id="8" name="Image 1" descr="preencoded.png">    </p:cNvPr>
+          <p:cNvPicPr>
+            <a:picLocks noChangeAspect="1"/>
+          </p:cNvPicPr>
+          <p:nvPr/>
+        </p:nvPicPr>
+        <p:blipFill>
+          <a:blip r:embed="rId2"/>
+          <a:stretch>
+            <a:fillRect/>
+          </a:stretch>
+        </p:blipFill>
+        <p:spPr>
+          <a:xfrm>
+            <a:off x="548640" y="4343400"/>
+            <a:ext cx="6949440" cy="1773936"/>
+          </a:xfrm>
+          <a:prstGeom prst="rect">
+            <a:avLst/>
+          </a:prstGeom>
+        </p:spPr>
+      </p:pic>
+      <p:sp>
+        <p:nvSpPr>
+          <p:cNvPr id="9" name="Shape 5"/>
+          <p:cNvSpPr/>
+          <p:nvPr/>
+        </p:nvSpPr>
+        <p:spPr>
+          <a:xfrm>
+            <a:off x="7680960" y="2148840"/>
+            <a:ext cx="3931920" cy="3968496"/>
+          </a:xfrm>
+          <a:prstGeom prst="roundRect">
+            <a:avLst>
+              <a:gd name="adj" fmla="val 2093"/>
+            </a:avLst>
+          </a:prstGeom>
+          <a:solidFill>
+            <a:srgbClr val="1A2350"/>
+          </a:solidFill>
+          <a:ln/>
+        </p:spPr>
+      </p:sp>
+      <p:sp>
+        <p:nvSpPr>
+          <p:cNvPr id="10" name="Text 6"/>
+          <p:cNvSpPr txBox="1"/>
+          <p:nvPr/>
+        </p:nvSpPr>
+        <p:spPr>
+          <a:xfrm>
+            <a:off x="7955280" y="2377440"/>
+            <a:ext cx="3383280" cy="365760"/>
+          </a:xfrm>
+          <a:prstGeom prst="rect">
+            <a:avLst/>
+          </a:prstGeom>
+          <a:noFill/>
+          <a:ln/>
+        </p:spPr>
+        <p:txBody>
+          <a:bodyPr wrap="square" lIns="0" tIns="0" rIns="0" bIns="0" rtlCol="0" anchor="ctr"/>
+          <a:lstStyle/>
+          <a:p>
+            <a:pPr indent="0" marL="0">
+              <a:buNone/>
+            </a:pPr>
+            <a:r>
+              <a:rPr lang="en-US" sz="1800" b="1" dirty="0">
+                <a:solidFill>
+                  <a:srgbClr val="F2B84B"/>
+                </a:solidFill>
+                <a:latin typeface="Cambria" pitchFamily="34" charset="0"/>
+                <a:ea typeface="Cambria" pitchFamily="34" charset="-122"/>
+                <a:cs typeface="Cambria" pitchFamily="34" charset="-120"/>
+              </a:rPr>
+              <a:t>Por qué importa</a:t>
+            </a:r>
+            <a:endParaRPr lang="en-US" sz="1800" dirty="0"/>
+          </a:p>
+        </p:txBody>
+      </p:sp>
+      <p:sp>
+        <p:nvSpPr>
+          <p:cNvPr id="11" name="Text 7"/>
+          <p:cNvSpPr txBox="1"/>
+          <p:nvPr/>
+        </p:nvSpPr>
+        <p:spPr>
+          <a:xfrm>
+            <a:off x="7955280" y="2834640"/>
+            <a:ext cx="3383280" cy="3108960"/>
+          </a:xfrm>
+          <a:prstGeom prst="rect">
+            <a:avLst/>
+          </a:prstGeom>
+          <a:noFill/>
+          <a:ln/>
+        </p:spPr>
+        <p:txBody>
+          <a:bodyPr wrap="square" lIns="0" tIns="0" rIns="0" bIns="0" rtlCol="0" anchor="ctr"/>
+          <a:lstStyle/>
+          <a:p>
+            <a:pPr indent="0" marL="0">
+              <a:lnSpc>
+                <a:spcPct val="120000"/>
+              </a:lnSpc>
+              <a:buNone/>
+            </a:pPr>
+            <a:r>
+              <a:rPr lang="en-US" sz="1400" b="1" dirty="0">
+                <a:solidFill>
+                  <a:srgbClr val="3AD6C6"/>
+                </a:solidFill>
+                <a:latin typeface="Calibri" pitchFamily="34" charset="0"/>
+                <a:ea typeface="Calibri" pitchFamily="34" charset="-122"/>
+                <a:cs typeface="Calibri" pitchFamily="34" charset="-120"/>
+              </a:rPr>
+              <a:t>Verificación de carga = True: </a:t>
+            </a:r>
+            <a:pPr indent="0" marL="0">
+              <a:lnSpc>
+                <a:spcPct val="120000"/>
+              </a:lnSpc>
+              <a:buNone/>
+            </a:pPr>
+            <a:r>
+              <a:rPr lang="en-US" sz="1400" dirty="0">
+                <a:solidFill>
+                  <a:srgbClr val="EAF0FF"/>
+                </a:solidFill>
+                <a:latin typeface="Calibri" pitchFamily="34" charset="0"/>
+                <a:ea typeface="Calibri" pitchFamily="34" charset="-122"/>
+                <a:cs typeface="Calibri" pitchFamily="34" charset="-120"/>
+              </a:rPr>
+              <a:t>el modelo serializado produce exactamente las mismas predicciones que antes de guardarlo. El artefacto es confiable.</a:t>
+            </a:r>
+            <a:endParaRPr lang="en-US" sz="1400" dirty="0"/>
+          </a:p>
+          <a:p>
+            <a:pPr indent="0" marL="0">
+              <a:lnSpc>
+                <a:spcPct val="120000"/>
+              </a:lnSpc>
+              <a:buNone/>
+            </a:pPr>
+            <a:endParaRPr lang="en-US" sz="1400" dirty="0"/>
+          </a:p>
+          <a:p>
+            <a:pPr indent="0" marL="0">
+              <a:lnSpc>
+                <a:spcPct val="120000"/>
+              </a:lnSpc>
+              <a:buNone/>
+            </a:pPr>
+            <a:r>
+              <a:rPr lang="en-US" sz="1400" b="1" dirty="0">
+                <a:solidFill>
+                  <a:srgbClr val="3AD6C6"/>
+                </a:solidFill>
+                <a:latin typeface="Calibri" pitchFamily="34" charset="0"/>
+                <a:ea typeface="Calibri" pitchFamily="34" charset="-122"/>
+                <a:cs typeface="Calibri" pitchFamily="34" charset="-120"/>
+              </a:rPr>
+              <a:t>Inferencia real: </a:t>
+            </a:r>
+            <a:endParaRPr lang="en-US" sz="1400" dirty="0"/>
+          </a:p>
+          <a:p>
+            <a:pPr indent="0" marL="0">
+              <a:lnSpc>
+                <a:spcPct val="120000"/>
+              </a:lnSpc>
+              <a:buNone/>
+            </a:pPr>
+            <a:r>
+              <a:rPr lang="en-US" sz="1400" dirty="0">
+                <a:solidFill>
+                  <a:srgbClr val="EAF0FF"/>
+                </a:solidFill>
+                <a:latin typeface="Calibri" pitchFamily="34" charset="0"/>
+                <a:ea typeface="Calibri" pitchFamily="34" charset="-122"/>
+                <a:cs typeface="Calibri" pitchFamily="34" charset="-120"/>
+              </a:rPr>
+              <a:t>cada predicción trae su probabilidad, el umbral usado (0.40) y el mensaje “requiere revisión humana”.</a:t>
+            </a:r>
+            <a:endParaRPr lang="en-US" sz="1400" dirty="0"/>
+          </a:p>
+        </p:txBody>
+      </p:sp>
+    </p:spTree>
+  </p:cSld>
+  <p:clrMapOvr>
+    <a:masterClrMapping/>
+  </p:clrMapOvr>
+</p:sld>
+</file>
+
+<file path=ppt/slides/slide18.xml><?xml version="1.0" encoding="utf-8"?>
+<p:sld xmlns:a="http://schemas.openxmlformats.org/drawingml/2006/main" xmlns:r="http://schemas.openxmlformats.org/officeDocument/2006/relationships" xmlns:p="http://schemas.openxmlformats.org/presentationml/2006/main">
+  <p:cSld name="Slide 18">
+    <p:bg>
+      <p:bgPr>
+        <a:solidFill>
+          <a:srgbClr val="0E1530"/>
+        </a:solidFill>
+      </p:bgPr>
+    </p:bg>
+    <p:spTree>
+      <p:nvGrpSpPr>
+        <p:cNvPr id="1" name=""/>
+        <p:cNvGrpSpPr/>
+        <p:nvPr/>
+      </p:nvGrpSpPr>
+      <p:grpSpPr>
+        <a:xfrm>
+          <a:off x="0" y="0"/>
+          <a:ext cx="0" cy="0"/>
+          <a:chOff x="0" y="0"/>
+          <a:chExt cx="0" cy="0"/>
+        </a:xfrm>
+      </p:grpSpPr>
+      <p:sp>
+        <p:nvSpPr>
+          <p:cNvPr id="2" name="Text 0"/>
+          <p:cNvSpPr txBox="1"/>
+          <p:nvPr/>
+        </p:nvSpPr>
+        <p:spPr>
+          <a:xfrm>
+            <a:off x="548640" y="457200"/>
+            <a:ext cx="8229600" cy="274320"/>
+          </a:xfrm>
+          <a:prstGeom prst="rect">
+            <a:avLst/>
+          </a:prstGeom>
+          <a:noFill/>
+          <a:ln/>
+        </p:spPr>
+        <p:txBody>
+          <a:bodyPr wrap="square" lIns="0" tIns="0" rIns="0" bIns="0" rtlCol="0" anchor="ctr"/>
+          <a:lstStyle/>
+          <a:p>
+            <a:pPr indent="0" marL="0">
+              <a:buNone/>
+            </a:pPr>
+            <a:r>
+              <a:rPr lang="en-US" sz="1200" b="1" spc="300" kern="0" dirty="0">
+                <a:solidFill>
+                  <a:srgbClr val="F2B84B"/>
+                </a:solidFill>
+                <a:latin typeface="Calibri" pitchFamily="34" charset="0"/>
+                <a:ea typeface="Calibri" pitchFamily="34" charset="-122"/>
+                <a:cs typeface="Calibri" pitchFamily="34" charset="-120"/>
+              </a:rPr>
+              <a:t>EVIDENCIA DE EJECUCIÓN</a:t>
+            </a:r>
+            <a:endParaRPr lang="en-US" sz="1200" dirty="0"/>
+          </a:p>
+        </p:txBody>
+      </p:sp>
+      <p:sp>
+        <p:nvSpPr>
+          <p:cNvPr id="3" name="Text 1"/>
+          <p:cNvSpPr txBox="1"/>
+          <p:nvPr/>
+        </p:nvSpPr>
+        <p:spPr>
+          <a:xfrm>
+            <a:off x="548640" y="749808"/>
+            <a:ext cx="11064240" cy="822960"/>
+          </a:xfrm>
+          <a:prstGeom prst="rect">
+            <a:avLst/>
+          </a:prstGeom>
+          <a:noFill/>
+          <a:ln/>
+        </p:spPr>
+        <p:txBody>
+          <a:bodyPr wrap="square" lIns="0" tIns="0" rIns="0" bIns="0" rtlCol="0" anchor="ctr"/>
+          <a:lstStyle/>
+          <a:p>
+            <a:pPr indent="0" marL="0">
+              <a:buNone/>
+            </a:pPr>
+            <a:r>
+              <a:rPr lang="en-US" sz="3400" b="1" dirty="0">
+                <a:solidFill>
+                  <a:srgbClr val="EAF0FF"/>
+                </a:solidFill>
+                <a:latin typeface="Cambria" pitchFamily="34" charset="0"/>
+                <a:ea typeface="Cambria" pitchFamily="34" charset="-122"/>
+                <a:cs typeface="Cambria" pitchFamily="34" charset="-120"/>
+              </a:rPr>
+              <a:t>Ejecución 3 · Simulación de 5 perfiles</a:t>
+            </a:r>
+            <a:endParaRPr lang="en-US" sz="3400" dirty="0"/>
+          </a:p>
+        </p:txBody>
+      </p:sp>
+      <p:sp>
+        <p:nvSpPr>
+          <p:cNvPr id="4" name="Text 2"/>
+          <p:cNvSpPr txBox="1"/>
+          <p:nvPr/>
+        </p:nvSpPr>
+        <p:spPr>
+          <a:xfrm>
+            <a:off x="11430000" y="6355080"/>
+            <a:ext cx="548640" cy="274320"/>
+          </a:xfrm>
+          <a:prstGeom prst="rect">
+            <a:avLst/>
+          </a:prstGeom>
+          <a:noFill/>
+          <a:ln/>
+        </p:spPr>
+        <p:txBody>
+          <a:bodyPr wrap="square" lIns="0" tIns="0" rIns="0" bIns="0" rtlCol="0" anchor="ctr"/>
+          <a:lstStyle/>
+          <a:p>
+            <a:pPr algn="r" indent="0" marL="0">
+              <a:buNone/>
+            </a:pPr>
+            <a:r>
+              <a:rPr lang="en-US" sz="1000" dirty="0">
+                <a:solidFill>
+                  <a:srgbClr val="97A6CF"/>
+                </a:solidFill>
+                <a:latin typeface="Calibri" pitchFamily="34" charset="0"/>
+                <a:ea typeface="Calibri" pitchFamily="34" charset="-122"/>
+                <a:cs typeface="Calibri" pitchFamily="34" charset="-120"/>
+              </a:rPr>
+              <a:t>18</a:t>
+            </a:r>
+            <a:endParaRPr lang="en-US" sz="1000" dirty="0"/>
+          </a:p>
+        </p:txBody>
+      </p:sp>
+      <p:pic>
+        <p:nvPicPr>
+          <p:cNvPr id="5" name="Image 0" descr="preencoded.png">    </p:cNvPr>
+          <p:cNvPicPr>
+            <a:picLocks noChangeAspect="1"/>
+          </p:cNvPicPr>
+          <p:nvPr/>
+        </p:nvPicPr>
+        <p:blipFill>
+          <a:blip r:embed="rId1"/>
+          <a:stretch>
+            <a:fillRect/>
+          </a:stretch>
+        </p:blipFill>
+        <p:spPr>
+          <a:xfrm>
+            <a:off x="548640" y="1965960"/>
+            <a:ext cx="7406640" cy="2377440"/>
+          </a:xfrm>
+          <a:prstGeom prst="rect">
+            <a:avLst/>
+          </a:prstGeom>
+        </p:spPr>
+      </p:pic>
+      <p:sp>
+        <p:nvSpPr>
+          <p:cNvPr id="6" name="Shape 3"/>
+          <p:cNvSpPr/>
+          <p:nvPr/>
+        </p:nvSpPr>
+        <p:spPr>
+          <a:xfrm>
+            <a:off x="548640" y="4663440"/>
+            <a:ext cx="11064240" cy="1737360"/>
+          </a:xfrm>
+          <a:prstGeom prst="roundRect">
+            <a:avLst>
+              <a:gd name="adj" fmla="val 4737"/>
+            </a:avLst>
+          </a:prstGeom>
+          <a:solidFill>
+            <a:srgbClr val="1A2350"/>
+          </a:solidFill>
+          <a:ln/>
+        </p:spPr>
+      </p:sp>
+      <p:sp>
+        <p:nvSpPr>
+          <p:cNvPr id="7" name="Text 4"/>
+          <p:cNvSpPr txBox="1"/>
+          <p:nvPr/>
+        </p:nvSpPr>
+        <p:spPr>
+          <a:xfrm>
+            <a:off x="868680" y="4846320"/>
+            <a:ext cx="10424160" cy="365760"/>
+          </a:xfrm>
+          <a:prstGeom prst="rect">
+            <a:avLst/>
+          </a:prstGeom>
+          <a:noFill/>
+          <a:ln/>
+        </p:spPr>
+        <p:txBody>
+          <a:bodyPr wrap="square" lIns="0" tIns="0" rIns="0" bIns="0" rtlCol="0" anchor="ctr"/>
+          <a:lstStyle/>
+          <a:p>
+            <a:pPr indent="0" marL="0">
+              <a:buNone/>
+            </a:pPr>
+            <a:r>
+              <a:rPr lang="en-US" sz="1800" b="1" dirty="0">
+                <a:solidFill>
+                  <a:srgbClr val="F2B84B"/>
+                </a:solidFill>
+                <a:latin typeface="Cambria" pitchFamily="34" charset="0"/>
+                <a:ea typeface="Cambria" pitchFamily="34" charset="-122"/>
+                <a:cs typeface="Cambria" pitchFamily="34" charset="-120"/>
+              </a:rPr>
+              <a:t>Cómo se lee</a:t>
+            </a:r>
+            <a:endParaRPr lang="en-US" sz="1800" dirty="0"/>
+          </a:p>
+        </p:txBody>
+      </p:sp>
+      <p:sp>
+        <p:nvSpPr>
+          <p:cNvPr id="8" name="Text 5"/>
+          <p:cNvSpPr txBox="1"/>
+          <p:nvPr/>
+        </p:nvSpPr>
+        <p:spPr>
+          <a:xfrm>
+            <a:off x="868680" y="5257800"/>
+            <a:ext cx="10424160" cy="1005840"/>
+          </a:xfrm>
+          <a:prstGeom prst="rect">
+            <a:avLst/>
+          </a:prstGeom>
+          <a:noFill/>
+          <a:ln/>
+        </p:spPr>
+        <p:txBody>
+          <a:bodyPr wrap="square" lIns="0" tIns="0" rIns="0" bIns="0" rtlCol="0" anchor="ctr"/>
+          <a:lstStyle/>
+          <a:p>
+            <a:pPr indent="0" marL="0">
+              <a:lnSpc>
+                <a:spcPct val="115000"/>
+              </a:lnSpc>
+              <a:buNone/>
+            </a:pPr>
+            <a:r>
+              <a:rPr lang="en-US" sz="1450" b="1" dirty="0">
+                <a:solidFill>
+                  <a:srgbClr val="3AD6C6"/>
+                </a:solidFill>
+                <a:latin typeface="Calibri" pitchFamily="34" charset="0"/>
+                <a:ea typeface="Calibri" pitchFamily="34" charset="-122"/>
+                <a:cs typeface="Calibri" pitchFamily="34" charset="-120"/>
+              </a:rPr>
+              <a:t>El perfil alto → 0.99 (LCK)</a:t>
+            </a:r>
+            <a:pPr indent="0" marL="0">
+              <a:lnSpc>
+                <a:spcPct val="115000"/>
+              </a:lnSpc>
+              <a:buNone/>
+            </a:pPr>
+            <a:r>
+              <a:rPr lang="en-US" sz="1450" dirty="0">
+                <a:solidFill>
+                  <a:srgbClr val="EAF0FF"/>
+                </a:solidFill>
+                <a:latin typeface="Calibri" pitchFamily="34" charset="0"/>
+                <a:ea typeface="Calibri" pitchFamily="34" charset="-122"/>
+                <a:cs typeface="Calibri" pitchFamily="34" charset="-120"/>
+              </a:rPr>
+              <a:t> y el bajo → 0.01 (LCK CL): el modelo separa los extremos con claridad.  </a:t>
+            </a:r>
+            <a:pPr indent="0" marL="0">
+              <a:lnSpc>
+                <a:spcPct val="115000"/>
+              </a:lnSpc>
+              <a:buNone/>
+            </a:pPr>
+            <a:r>
+              <a:rPr lang="en-US" sz="1450" b="1" dirty="0">
+                <a:solidFill>
+                  <a:srgbClr val="F2B84B"/>
+                </a:solidFill>
+                <a:latin typeface="Calibri" pitchFamily="34" charset="0"/>
+                <a:ea typeface="Calibri" pitchFamily="34" charset="-122"/>
+                <a:cs typeface="Calibri" pitchFamily="34" charset="-120"/>
+              </a:rPr>
+              <a:t>El “cercano al umbral” → 0.40</a:t>
+            </a:r>
+            <a:pPr indent="0" marL="0">
+              <a:lnSpc>
+                <a:spcPct val="115000"/>
+              </a:lnSpc>
+              <a:buNone/>
+            </a:pPr>
+            <a:r>
+              <a:rPr lang="en-US" sz="1450" dirty="0">
+                <a:solidFill>
+                  <a:srgbClr val="EAF0FF"/>
+                </a:solidFill>
+                <a:latin typeface="Calibri" pitchFamily="34" charset="0"/>
+                <a:ea typeface="Calibri" pitchFamily="34" charset="-122"/>
+                <a:cs typeface="Calibri" pitchFamily="34" charset="-120"/>
+              </a:rPr>
+              <a:t> es un caso dudoso que SIEMPRE necesita ojo humano.  </a:t>
+            </a:r>
+            <a:pPr indent="0" marL="0">
+              <a:lnSpc>
+                <a:spcPct val="115000"/>
+              </a:lnSpc>
+              <a:buNone/>
+            </a:pPr>
+            <a:r>
+              <a:rPr lang="en-US" sz="1450" b="1" dirty="0">
+                <a:solidFill>
+                  <a:srgbClr val="F0714A"/>
+                </a:solidFill>
+                <a:latin typeface="Calibri" pitchFamily="34" charset="0"/>
+                <a:ea typeface="Calibri" pitchFamily="34" charset="-122"/>
+                <a:cs typeface="Calibri" pitchFamily="34" charset="-120"/>
+              </a:rPr>
+              <a:t>La categoría rara (posición ‘jungla’, desconocida)</a:t>
+            </a:r>
+            <a:pPr indent="0" marL="0">
+              <a:lnSpc>
+                <a:spcPct val="115000"/>
+              </a:lnSpc>
+              <a:buNone/>
+            </a:pPr>
+            <a:r>
+              <a:rPr lang="en-US" sz="1450" dirty="0">
+                <a:solidFill>
+                  <a:srgbClr val="EAF0FF"/>
+                </a:solidFill>
+                <a:latin typeface="Calibri" pitchFamily="34" charset="0"/>
+                <a:ea typeface="Calibri" pitchFamily="34" charset="-122"/>
+                <a:cs typeface="Calibri" pitchFamily="34" charset="-120"/>
+              </a:rPr>
+              <a:t> se procesa sin romper. Ninguna decisión se automatiza.</a:t>
+            </a:r>
+            <a:endParaRPr lang="en-US" sz="1450" dirty="0"/>
+          </a:p>
+        </p:txBody>
+      </p:sp>
+    </p:spTree>
+  </p:cSld>
+  <p:clrMapOvr>
+    <a:masterClrMapping/>
+  </p:clrMapOvr>
+</p:sld>
+</file>
+
+<file path=ppt/slides/slide19.xml><?xml version="1.0" encoding="utf-8"?>
+<p:sld xmlns:a="http://schemas.openxmlformats.org/drawingml/2006/main" xmlns:r="http://schemas.openxmlformats.org/officeDocument/2006/relationships" xmlns:p="http://schemas.openxmlformats.org/presentationml/2006/main">
+  <p:cSld name="Slide 19">
+    <p:bg>
+      <p:bgPr>
+        <a:solidFill>
           <a:srgbClr val="141C3D"/>
         </a:solidFill>
       </p:bgPr>
@@ -8130,7 +9560,7 @@
                 <a:ea typeface="Calibri" pitchFamily="34" charset="-122"/>
                 <a:cs typeface="Calibri" pitchFamily="34" charset="-120"/>
               </a:rPr>
-              <a:t>16</a:t>
+              <a:t>19</a:t>
             </a:r>
             <a:endParaRPr lang="en-US" sz="1000" dirty="0"/>
           </a:p>

</xml_diff>